<commit_message>
add ablation and runtime slides
</commit_message>
<xml_diff>
--- a/slides/term_project_presentation_SYNGAS--group 6 Ying.pptx
+++ b/slides/term_project_presentation_SYNGAS--group 6 Ying.pptx
@@ -21,6 +21,8 @@
     <p:sldId id="266" r:id="rId14"/>
     <p:sldId id="267" r:id="rId15"/>
     <p:sldId id="268" r:id="rId16"/>
+    <p:sldId id="269" r:id="rId21"/>
+    <p:sldId id="270" r:id="rId22"/>
   </p:sldIdLst>
   <p:sldSz cx="9144000" cy="6858000" type="screen4x3"/>
   <p:notesSz cx="6858000" cy="9144000"/>
@@ -4866,32 +4868,19 @@
           </a:bodyPr>
           <a:lstStyle/>
           <a:p>
-            <a:pPr algn="ctr">
-              <a:defRPr sz="1800">
-                <a:solidFill>
-                  <a:srgbClr val="646464"/>
-                </a:solidFill>
-              </a:defRPr>
-            </a:pPr>
-            <a:r>
-              <a:rPr/>
+            <a:r>
               <a:t>Solo Project - Student: Ying Tan</a:t>
             </a:r>
-            <a:endParaRPr/>
-          </a:p>
-          <a:p>
-            <a:pPr algn="ctr">
-              <a:defRPr sz="1800">
-                <a:solidFill>
-                  <a:srgbClr val="646464"/>
-                </a:solidFill>
-              </a:defRPr>
-            </a:pPr>
-            <a:r>
-              <a:rPr/>
+          </a:p>
+          <a:p>
+            <a:r>
               <a:t>Machine Learning (CIS 732 ) - Spring 2026</a:t>
             </a:r>
-            <a:endParaRPr/>
+          </a:p>
+          <a:p>
+            <a:r>
+              <a:t>Updated: May 10, 2026 (Ablation + Runtime Added)</a:t>
+            </a:r>
           </a:p>
         </p:txBody>
       </p:sp>
@@ -6471,6 +6460,228 @@
       <p:transition advClick="1"/>
     </mc:Fallback>
   </mc:AlternateContent>
+</p:sld>
+</file>
+
+<file path=ppt/slides/slide14.xml><?xml version="1.0" encoding="utf-8"?>
+<p:sld xmlns:a="http://schemas.openxmlformats.org/drawingml/2006/main" xmlns:p="http://schemas.openxmlformats.org/presentationml/2006/main" xmlns:r="http://schemas.openxmlformats.org/officeDocument/2006/relationships">
+  <p:cSld>
+    <p:spTree>
+      <p:nvGrpSpPr>
+        <p:cNvPr id="1" name=""/>
+        <p:cNvGrpSpPr/>
+        <p:nvPr/>
+      </p:nvGrpSpPr>
+      <p:grpSpPr/>
+      <p:sp>
+        <p:nvSpPr>
+          <p:cNvPr id="2" name="Title 1"/>
+          <p:cNvSpPr>
+            <a:spLocks noGrp="1"/>
+          </p:cNvSpPr>
+          <p:nvPr>
+            <p:ph type="title"/>
+          </p:nvPr>
+        </p:nvSpPr>
+        <p:spPr/>
+        <p:txBody>
+          <a:bodyPr/>
+          <a:lstStyle/>
+          <a:p>
+            <a:r>
+              <a:t>NEW: Scaling Ablation (4 Combinations)</a:t>
+            </a:r>
+          </a:p>
+        </p:txBody>
+      </p:sp>
+      <p:sp>
+        <p:nvSpPr>
+          <p:cNvPr id="3" name="Content Placeholder 2"/>
+          <p:cNvSpPr>
+            <a:spLocks noGrp="1"/>
+          </p:cNvSpPr>
+          <p:nvPr>
+            <p:ph idx="1"/>
+          </p:nvPr>
+        </p:nvSpPr>
+        <p:spPr/>
+        <p:txBody>
+          <a:bodyPr/>
+          <a:lstStyle/>
+          <a:p>
+            <a:pPr>
+              <a:defRPr sz="1600"/>
+            </a:pPr>
+            <a:r>
+              <a:t>Fixed split (seed=42), exact 4-combo test required by feedback:</a:t>
+            </a:r>
+          </a:p>
+          <a:p>
+            <a:pPr>
+              <a:defRPr sz="1400"/>
+            </a:pPr>
+            <a:r>
+              <a:t>1) MLP scaled + RF unscaled:   RF RMSE=4.3706, MLP RMSE=5.5337</a:t>
+            </a:r>
+          </a:p>
+          <a:p>
+            <a:pPr>
+              <a:defRPr sz="1400"/>
+            </a:pPr>
+            <a:r>
+              <a:t>2) MLP scaled + RF scaled:     RF RMSE=4.7972, MLP RMSE=5.5337</a:t>
+            </a:r>
+          </a:p>
+          <a:p>
+            <a:pPr>
+              <a:defRPr sz="1400"/>
+            </a:pPr>
+            <a:r>
+              <a:t>3) MLP unscaled + RF unscaled: RF RMSE=4.3706, MLP RMSE=5.3398</a:t>
+            </a:r>
+          </a:p>
+          <a:p>
+            <a:pPr>
+              <a:defRPr sz="1400"/>
+            </a:pPr>
+            <a:r>
+              <a:t>4) MLP unscaled + RF scaled:   RF RMSE=4.7972, MLP RMSE=5.3398</a:t>
+            </a:r>
+          </a:p>
+          <a:p>
+            <a:pPr>
+              <a:defRPr sz="1400"/>
+            </a:pPr>
+            <a:r>
+              <a:t>Finding: RF is best when unscaled in this dataset; scaling RF degrades RMSE.</a:t>
+            </a:r>
+          </a:p>
+          <a:p>
+            <a:pPr>
+              <a:defRPr sz="1400"/>
+            </a:pPr>
+            <a:r>
+              <a:t>Finding: MLP is sensitive but not catastrophically unstable in either setting.</a:t>
+            </a:r>
+          </a:p>
+          <a:p>
+            <a:pPr>
+              <a:defRPr sz="1400"/>
+            </a:pPr>
+            <a:r>
+              <a:t>Evidence files: scripts/scaling_ablation_results.csv, figures/fig12_scaling_ablation_rmse.png</a:t>
+            </a:r>
+          </a:p>
+        </p:txBody>
+      </p:sp>
+    </p:spTree>
+  </p:cSld>
+  <p:clrMapOvr>
+    <a:masterClrMapping/>
+  </p:clrMapOvr>
+</p:sld>
+</file>
+
+<file path=ppt/slides/slide15.xml><?xml version="1.0" encoding="utf-8"?>
+<p:sld xmlns:a="http://schemas.openxmlformats.org/drawingml/2006/main" xmlns:p="http://schemas.openxmlformats.org/presentationml/2006/main" xmlns:r="http://schemas.openxmlformats.org/officeDocument/2006/relationships">
+  <p:cSld>
+    <p:spTree>
+      <p:nvGrpSpPr>
+        <p:cNvPr id="1" name=""/>
+        <p:cNvGrpSpPr/>
+        <p:nvPr/>
+      </p:nvGrpSpPr>
+      <p:grpSpPr/>
+      <p:sp>
+        <p:nvSpPr>
+          <p:cNvPr id="2" name="Title 1"/>
+          <p:cNvSpPr>
+            <a:spLocks noGrp="1"/>
+          </p:cNvSpPr>
+          <p:nvPr>
+            <p:ph type="title"/>
+          </p:nvPr>
+        </p:nvSpPr>
+        <p:spPr/>
+        <p:txBody>
+          <a:bodyPr/>
+          <a:lstStyle/>
+          <a:p>
+            <a:r>
+              <a:t>NEW: Wall-Clock Runtime (Train + Inference)</a:t>
+            </a:r>
+          </a:p>
+        </p:txBody>
+      </p:sp>
+      <p:sp>
+        <p:nvSpPr>
+          <p:cNvPr id="3" name="Content Placeholder 2"/>
+          <p:cNvSpPr>
+            <a:spLocks noGrp="1"/>
+          </p:cNvSpPr>
+          <p:nvPr>
+            <p:ph idx="1"/>
+          </p:nvPr>
+        </p:nvSpPr>
+        <p:spPr/>
+        <p:txBody>
+          <a:bodyPr/>
+          <a:lstStyle/>
+          <a:p>
+            <a:pPr>
+              <a:defRPr sz="1600"/>
+            </a:pPr>
+            <a:r>
+              <a:t>Runtime measured for each ablation combo on same hardware:</a:t>
+            </a:r>
+          </a:p>
+          <a:p>
+            <a:pPr>
+              <a:defRPr sz="1400"/>
+            </a:pPr>
+            <a:r>
+              <a:t>RF training time:  0.085s to 0.091s</a:t>
+            </a:r>
+          </a:p>
+          <a:p>
+            <a:pPr>
+              <a:defRPr sz="1400"/>
+            </a:pPr>
+            <a:r>
+              <a:t>MLP training time: 0.278s to 0.284s</a:t>
+            </a:r>
+          </a:p>
+          <a:p>
+            <a:pPr>
+              <a:defRPr sz="1400"/>
+            </a:pPr>
+            <a:r>
+              <a:t>Inference latency: both models are sub-millisecond per sample.</a:t>
+            </a:r>
+          </a:p>
+          <a:p>
+            <a:pPr>
+              <a:defRPr sz="1400"/>
+            </a:pPr>
+            <a:r>
+              <a:t>For deployment decision in this project: generalization robustness matters more than speed.</a:t>
+            </a:r>
+          </a:p>
+          <a:p>
+            <a:pPr>
+              <a:defRPr sz="1400"/>
+            </a:pPr>
+            <a:r>
+              <a:t>Evidence figure: figures/fig13_runtime_ablation.png</a:t>
+            </a:r>
+          </a:p>
+        </p:txBody>
+      </p:sp>
+    </p:spTree>
+  </p:cSld>
+  <p:clrMapOvr>
+    <a:masterClrMapping/>
+  </p:clrMapOvr>
 </p:sld>
 </file>
 

</xml_diff>